<commit_message>
Fix scorecard acceptance issues
</commit_message>
<xml_diff>
--- a/docs/samples/monthly-kpi-scorecard-portfolio-may-2026.pptx
+++ b/docs/samples/monthly-kpi-scorecard-portfolio-may-2026.pptx
@@ -4861,7 +4861,7 @@
                           <a:ea typeface="Aptos" pitchFamily="34" charset="-122"/>
                           <a:cs typeface="Aptos" pitchFamily="34" charset="-120"/>
                         </a:rPr>
-                        <a:t>101.00%</a:t>
+                        <a:t>99.00%</a:t>
                       </a:r>
                       <a:endParaRPr lang="en-US" sz="1600">
                         <a:solidFill>
@@ -4932,7 +4932,7 @@
                           <a:ea typeface="Aptos" pitchFamily="34" charset="-122"/>
                           <a:cs typeface="Aptos" pitchFamily="34" charset="-120"/>
                         </a:rPr>
-                        <a:t>88.00% (7.3:1)</a:t>
+                        <a:t>85.00% (5.7:1)</a:t>
                       </a:r>
                       <a:endParaRPr lang="en-US" sz="1600">
                         <a:solidFill>
@@ -4982,7 +4982,7 @@
                       <a:tailEnd type="none" w="med" len="med"/>
                     </a:lnB>
                     <a:solidFill>
-                      <a:srgbClr val="00B050"/>
+                      <a:srgbClr val="FFC000"/>
                     </a:solidFill>
                   </a:tcPr>
                 </a:tc>
@@ -5003,7 +5003,7 @@
                           <a:ea typeface="Aptos" pitchFamily="34" charset="-122"/>
                           <a:cs typeface="Aptos" pitchFamily="34" charset="-120"/>
                         </a:rPr>
-                        <a:t>64.00% (1.8:1)</a:t>
+                        <a:t>58.00% (1.4:1)</a:t>
                       </a:r>
                       <a:endParaRPr lang="en-US" sz="1600">
                         <a:solidFill>
@@ -5053,7 +5053,7 @@
                       <a:tailEnd type="none" w="med" len="med"/>
                     </a:lnB>
                     <a:solidFill>
-                      <a:srgbClr val="00B050"/>
+                      <a:srgbClr val="FFC000"/>
                     </a:solidFill>
                   </a:tcPr>
                 </a:tc>
@@ -5145,7 +5145,7 @@
                           <a:ea typeface="Aptos" pitchFamily="34" charset="-122"/>
                           <a:cs typeface="Aptos" pitchFamily="34" charset="-120"/>
                         </a:rPr>
-                        <a:t>99.98%</a:t>
+                        <a:t>99.96%</a:t>
                       </a:r>
                       <a:endParaRPr lang="en-US" sz="1600">
                         <a:solidFill>
@@ -5195,7 +5195,7 @@
                       <a:tailEnd type="none" w="med" len="med"/>
                     </a:lnB>
                     <a:solidFill>
-                      <a:srgbClr val="00B050"/>
+                      <a:srgbClr val="FFC000"/>
                     </a:solidFill>
                   </a:tcPr>
                 </a:tc>
@@ -5291,7 +5291,7 @@
                           <a:ea typeface="Aptos" pitchFamily="34" charset="-122"/>
                           <a:cs typeface="Aptos" pitchFamily="34" charset="-120"/>
                         </a:rPr>
-                        <a:t>109.00%</a:t>
+                        <a:t>97.00%</a:t>
                       </a:r>
                       <a:endParaRPr lang="en-US" sz="1600">
                         <a:solidFill>
@@ -5362,7 +5362,7 @@
                           <a:ea typeface="Aptos" pitchFamily="34" charset="-122"/>
                           <a:cs typeface="Aptos" pitchFamily="34" charset="-120"/>
                         </a:rPr>
-                        <a:t>44.50%</a:t>
+                        <a:t>100.00%</a:t>
                       </a:r>
                       <a:endParaRPr lang="en-US" sz="1600">
                         <a:solidFill>
@@ -5412,7 +5412,7 @@
                       <a:tailEnd type="none" w="med" len="med"/>
                     </a:lnB>
                     <a:solidFill>
-                      <a:srgbClr val="C00000"/>
+                      <a:srgbClr val="00B050"/>
                     </a:solidFill>
                   </a:tcPr>
                 </a:tc>
@@ -5433,7 +5433,7 @@
                           <a:ea typeface="Aptos" pitchFamily="34" charset="-122"/>
                           <a:cs typeface="Aptos" pitchFamily="34" charset="-120"/>
                         </a:rPr>
-                        <a:t>89.00% (8.1:1)</a:t>
+                        <a:t>86.00% (6.1:1)</a:t>
                       </a:r>
                       <a:endParaRPr lang="en-US" sz="1600">
                         <a:solidFill>
@@ -5575,7 +5575,7 @@
                           <a:ea typeface="Aptos" charset="0"/>
                           <a:cs typeface="Aptos" charset="0"/>
                         </a:rPr>
-                        <a:t>1.22 days</a:t>
+                        <a:t>3.50 days</a:t>
                       </a:r>
                     </a:p>
                   </a:txBody>
@@ -5638,7 +5638,7 @@
                           <a:ea typeface="Aptos" pitchFamily="34" charset="-122"/>
                           <a:cs typeface="Aptos" pitchFamily="34" charset="-120"/>
                         </a:rPr>
-                        <a:t>99.95%</a:t>
+                        <a:t>99.90%</a:t>
                       </a:r>
                       <a:endParaRPr lang="en-US" sz="1600">
                         <a:solidFill>
@@ -5784,7 +5784,7 @@
                           <a:ea typeface="Aptos" pitchFamily="34" charset="-122"/>
                           <a:cs typeface="Aptos" pitchFamily="34" charset="-120"/>
                         </a:rPr>
-                        <a:t>99.00%</a:t>
+                        <a:t>98.00%</a:t>
                       </a:r>
                       <a:endParaRPr lang="en-US" sz="1600">
                         <a:solidFill>
@@ -5855,79 +5855,8 @@
                           <a:ea typeface="Aptos" charset="0"/>
                           <a:cs typeface="Aptos" charset="0"/>
                         </a:rPr>
-                        <a:t>149.00%</a:t>
+                        <a:t>101.00%</a:t>
                       </a:r>
-                    </a:p>
-                  </a:txBody>
-                  <a:tcPr marL="36576" marR="36576" marT="27432" marB="27432" anchor="ctr">
-                    <a:lnL w="6350" cap="flat" cmpd="sng" algn="ctr">
-                      <a:solidFill>
-                        <a:srgbClr val="E5E7EB"/>
-                      </a:solidFill>
-                      <a:prstDash val="solid"/>
-                      <a:round/>
-                      <a:headEnd type="none" w="med" len="med"/>
-                      <a:tailEnd type="none" w="med" len="med"/>
-                    </a:lnL>
-                    <a:lnR w="6350" cap="flat" cmpd="sng" algn="ctr">
-                      <a:solidFill>
-                        <a:srgbClr val="E5E7EB"/>
-                      </a:solidFill>
-                      <a:prstDash val="solid"/>
-                      <a:round/>
-                      <a:headEnd type="none" w="med" len="med"/>
-                      <a:tailEnd type="none" w="med" len="med"/>
-                    </a:lnR>
-                    <a:lnT w="6350" cap="flat" cmpd="sng" algn="ctr">
-                      <a:solidFill>
-                        <a:srgbClr val="E5E7EB"/>
-                      </a:solidFill>
-                      <a:prstDash val="solid"/>
-                      <a:round/>
-                      <a:headEnd type="none" w="med" len="med"/>
-                      <a:tailEnd type="none" w="med" len="med"/>
-                    </a:lnT>
-                    <a:lnB w="6350" cap="flat" cmpd="sng" algn="ctr">
-                      <a:solidFill>
-                        <a:srgbClr val="E5E7EB"/>
-                      </a:solidFill>
-                      <a:prstDash val="solid"/>
-                      <a:round/>
-                      <a:headEnd type="none" w="med" len="med"/>
-                      <a:tailEnd type="none" w="med" len="med"/>
-                    </a:lnB>
-                    <a:solidFill>
-                      <a:srgbClr val="C00000"/>
-                    </a:solidFill>
-                  </a:tcPr>
-                </a:tc>
-                <a:tc>
-                  <a:txBody>
-                    <a:bodyPr/>
-                    <a:lstStyle/>
-                    <a:p>
-                      <a:pPr marL="0" indent="0" algn="ctr">
-                        <a:buNone/>
-                      </a:pPr>
-                      <a:r>
-                        <a:rPr lang="en-US" sz="1600">
-                          <a:solidFill>
-                            <a:schemeClr val="tx1"/>
-                          </a:solidFill>
-                          <a:latin typeface="Aptos Display"/>
-                          <a:ea typeface="Aptos" pitchFamily="34" charset="-122"/>
-                          <a:cs typeface="Aptos" pitchFamily="34" charset="-120"/>
-                        </a:rPr>
-                        <a:t>88.00% (7.3:1)</a:t>
-                      </a:r>
-                      <a:endParaRPr lang="en-US" sz="1600">
-                        <a:solidFill>
-                          <a:schemeClr val="tx1"/>
-                        </a:solidFill>
-                        <a:latin typeface="Aptos Display"/>
-                        <a:ea typeface="Aptos" charset="0"/>
-                        <a:cs typeface="Aptos" charset="0"/>
-                      </a:endParaRPr>
                     </a:p>
                   </a:txBody>
                   <a:tcPr marL="36576" marR="36576" marT="27432" marB="27432" anchor="ctr">
@@ -5989,7 +5918,7 @@
                           <a:ea typeface="Aptos" pitchFamily="34" charset="-122"/>
                           <a:cs typeface="Aptos" pitchFamily="34" charset="-120"/>
                         </a:rPr>
-                        <a:t>31.00% (0.4:1)</a:t>
+                        <a:t>87.00% (6.7:1)</a:t>
                       </a:r>
                       <a:endParaRPr lang="en-US" sz="1600">
                         <a:solidFill>
@@ -5999,69 +5928,6 @@
                         <a:ea typeface="Aptos" charset="0"/>
                         <a:cs typeface="Aptos" charset="0"/>
                       </a:endParaRPr>
-                    </a:p>
-                  </a:txBody>
-                  <a:tcPr marL="36576" marR="36576" marT="27432" marB="27432" anchor="ctr">
-                    <a:lnL w="6350" cap="flat" cmpd="sng" algn="ctr">
-                      <a:solidFill>
-                        <a:srgbClr val="E5E7EB"/>
-                      </a:solidFill>
-                      <a:prstDash val="solid"/>
-                      <a:round/>
-                      <a:headEnd type="none" w="med" len="med"/>
-                      <a:tailEnd type="none" w="med" len="med"/>
-                    </a:lnL>
-                    <a:lnR w="6350" cap="flat" cmpd="sng" algn="ctr">
-                      <a:solidFill>
-                        <a:srgbClr val="E5E7EB"/>
-                      </a:solidFill>
-                      <a:prstDash val="solid"/>
-                      <a:round/>
-                      <a:headEnd type="none" w="med" len="med"/>
-                      <a:tailEnd type="none" w="med" len="med"/>
-                    </a:lnR>
-                    <a:lnT w="6350" cap="flat" cmpd="sng" algn="ctr">
-                      <a:solidFill>
-                        <a:srgbClr val="E5E7EB"/>
-                      </a:solidFill>
-                      <a:prstDash val="solid"/>
-                      <a:round/>
-                      <a:headEnd type="none" w="med" len="med"/>
-                      <a:tailEnd type="none" w="med" len="med"/>
-                    </a:lnT>
-                    <a:lnB w="6350" cap="flat" cmpd="sng" algn="ctr">
-                      <a:solidFill>
-                        <a:srgbClr val="E5E7EB"/>
-                      </a:solidFill>
-                      <a:prstDash val="solid"/>
-                      <a:round/>
-                      <a:headEnd type="none" w="med" len="med"/>
-                      <a:tailEnd type="none" w="med" len="med"/>
-                    </a:lnB>
-                    <a:solidFill>
-                      <a:srgbClr val="C00000"/>
-                    </a:solidFill>
-                  </a:tcPr>
-                </a:tc>
-                <a:tc>
-                  <a:txBody>
-                    <a:bodyPr/>
-                    <a:lstStyle/>
-                    <a:p>
-                      <a:pPr marL="0" indent="0" algn="ctr">
-                        <a:buNone/>
-                      </a:pPr>
-                      <a:r>
-                        <a:rPr lang="en-US" sz="1600">
-                          <a:solidFill>
-                            <a:schemeClr val="tx1"/>
-                          </a:solidFill>
-                          <a:latin typeface="Aptos Display"/>
-                          <a:ea typeface="Aptos" charset="0"/>
-                          <a:cs typeface="Aptos" charset="0"/>
-                        </a:rPr>
-                        <a:t>0.61 days</a:t>
-                      </a:r>
                     </a:p>
                   </a:txBody>
                   <a:tcPr marL="36576" marR="36576" marT="27432" marB="27432" anchor="ctr">
@@ -6123,7 +5989,7 @@
                           <a:ea typeface="Aptos" pitchFamily="34" charset="-122"/>
                           <a:cs typeface="Aptos" pitchFamily="34" charset="-120"/>
                         </a:rPr>
-                        <a:t>93.80%</a:t>
+                        <a:t>62.00% (1.6:1)</a:t>
                       </a:r>
                       <a:endParaRPr lang="en-US" sz="1600">
                         <a:solidFill>
@@ -6173,7 +6039,141 @@
                       <a:tailEnd type="none" w="med" len="med"/>
                     </a:lnB>
                     <a:solidFill>
-                      <a:srgbClr val="C00000"/>
+                      <a:srgbClr val="00B050"/>
+                    </a:solidFill>
+                  </a:tcPr>
+                </a:tc>
+                <a:tc>
+                  <a:txBody>
+                    <a:bodyPr/>
+                    <a:lstStyle/>
+                    <a:p>
+                      <a:pPr marL="0" indent="0" algn="ctr">
+                        <a:buNone/>
+                      </a:pPr>
+                      <a:r>
+                        <a:rPr lang="en-US" sz="1600">
+                          <a:solidFill>
+                            <a:schemeClr val="tx1"/>
+                          </a:solidFill>
+                          <a:latin typeface="Aptos Display"/>
+                          <a:ea typeface="Aptos" charset="0"/>
+                          <a:cs typeface="Aptos" charset="0"/>
+                        </a:rPr>
+                        <a:t>3.80 days</a:t>
+                      </a:r>
+                    </a:p>
+                  </a:txBody>
+                  <a:tcPr marL="36576" marR="36576" marT="27432" marB="27432" anchor="ctr">
+                    <a:lnL w="6350" cap="flat" cmpd="sng" algn="ctr">
+                      <a:solidFill>
+                        <a:srgbClr val="E5E7EB"/>
+                      </a:solidFill>
+                      <a:prstDash val="solid"/>
+                      <a:round/>
+                      <a:headEnd type="none" w="med" len="med"/>
+                      <a:tailEnd type="none" w="med" len="med"/>
+                    </a:lnL>
+                    <a:lnR w="6350" cap="flat" cmpd="sng" algn="ctr">
+                      <a:solidFill>
+                        <a:srgbClr val="E5E7EB"/>
+                      </a:solidFill>
+                      <a:prstDash val="solid"/>
+                      <a:round/>
+                      <a:headEnd type="none" w="med" len="med"/>
+                      <a:tailEnd type="none" w="med" len="med"/>
+                    </a:lnR>
+                    <a:lnT w="6350" cap="flat" cmpd="sng" algn="ctr">
+                      <a:solidFill>
+                        <a:srgbClr val="E5E7EB"/>
+                      </a:solidFill>
+                      <a:prstDash val="solid"/>
+                      <a:round/>
+                      <a:headEnd type="none" w="med" len="med"/>
+                      <a:tailEnd type="none" w="med" len="med"/>
+                    </a:lnT>
+                    <a:lnB w="6350" cap="flat" cmpd="sng" algn="ctr">
+                      <a:solidFill>
+                        <a:srgbClr val="E5E7EB"/>
+                      </a:solidFill>
+                      <a:prstDash val="solid"/>
+                      <a:round/>
+                      <a:headEnd type="none" w="med" len="med"/>
+                      <a:tailEnd type="none" w="med" len="med"/>
+                    </a:lnB>
+                    <a:solidFill>
+                      <a:srgbClr val="00B050"/>
+                    </a:solidFill>
+                  </a:tcPr>
+                </a:tc>
+                <a:tc>
+                  <a:txBody>
+                    <a:bodyPr/>
+                    <a:lstStyle/>
+                    <a:p>
+                      <a:pPr marL="0" indent="0" algn="ctr">
+                        <a:buNone/>
+                      </a:pPr>
+                      <a:r>
+                        <a:rPr lang="en-US" sz="1600">
+                          <a:solidFill>
+                            <a:schemeClr val="tx1"/>
+                          </a:solidFill>
+                          <a:latin typeface="Aptos Display"/>
+                          <a:ea typeface="Aptos" pitchFamily="34" charset="-122"/>
+                          <a:cs typeface="Aptos" pitchFamily="34" charset="-120"/>
+                        </a:rPr>
+                        <a:t>99.93%</a:t>
+                      </a:r>
+                      <a:endParaRPr lang="en-US" sz="1600">
+                        <a:solidFill>
+                          <a:schemeClr val="tx1"/>
+                        </a:solidFill>
+                        <a:latin typeface="Aptos Display"/>
+                        <a:ea typeface="Aptos" charset="0"/>
+                        <a:cs typeface="Aptos" charset="0"/>
+                      </a:endParaRPr>
+                    </a:p>
+                  </a:txBody>
+                  <a:tcPr marL="36576" marR="36576" marT="27432" marB="27432" anchor="ctr">
+                    <a:lnL w="6350" cap="flat" cmpd="sng" algn="ctr">
+                      <a:solidFill>
+                        <a:srgbClr val="E5E7EB"/>
+                      </a:solidFill>
+                      <a:prstDash val="solid"/>
+                      <a:round/>
+                      <a:headEnd type="none" w="med" len="med"/>
+                      <a:tailEnd type="none" w="med" len="med"/>
+                    </a:lnL>
+                    <a:lnR w="6350" cap="flat" cmpd="sng" algn="ctr">
+                      <a:solidFill>
+                        <a:srgbClr val="E5E7EB"/>
+                      </a:solidFill>
+                      <a:prstDash val="solid"/>
+                      <a:round/>
+                      <a:headEnd type="none" w="med" len="med"/>
+                      <a:tailEnd type="none" w="med" len="med"/>
+                    </a:lnR>
+                    <a:lnT w="6350" cap="flat" cmpd="sng" algn="ctr">
+                      <a:solidFill>
+                        <a:srgbClr val="E5E7EB"/>
+                      </a:solidFill>
+                      <a:prstDash val="solid"/>
+                      <a:round/>
+                      <a:headEnd type="none" w="med" len="med"/>
+                      <a:tailEnd type="none" w="med" len="med"/>
+                    </a:lnT>
+                    <a:lnB w="6350" cap="flat" cmpd="sng" algn="ctr">
+                      <a:solidFill>
+                        <a:srgbClr val="E5E7EB"/>
+                      </a:solidFill>
+                      <a:prstDash val="solid"/>
+                      <a:round/>
+                      <a:headEnd type="none" w="med" len="med"/>
+                      <a:tailEnd type="none" w="med" len="med"/>
+                    </a:lnB>
+                    <a:solidFill>
+                      <a:srgbClr val="FFC000"/>
                     </a:solidFill>
                   </a:tcPr>
                 </a:tc>
@@ -6269,7 +6269,7 @@
                           <a:ea typeface="Aptos" pitchFamily="34" charset="-122"/>
                           <a:cs typeface="Aptos" pitchFamily="34" charset="-120"/>
                         </a:rPr>
-                        <a:t>54.00%</a:t>
+                        <a:t>95.00%</a:t>
                       </a:r>
                       <a:endParaRPr lang="en-US" sz="1600">
                         <a:solidFill>
@@ -6319,7 +6319,7 @@
                       <a:tailEnd type="none" w="med" len="med"/>
                     </a:lnB>
                     <a:solidFill>
-                      <a:srgbClr val="C00000"/>
+                      <a:srgbClr val="00B050"/>
                     </a:solidFill>
                   </a:tcPr>
                 </a:tc>
@@ -6340,7 +6340,7 @@
                           <a:ea typeface="Aptos" pitchFamily="34" charset="-122"/>
                           <a:cs typeface="Aptos" pitchFamily="34" charset="-120"/>
                         </a:rPr>
-                        <a:t>87.00%</a:t>
+                        <a:t>98.00%</a:t>
                       </a:r>
                       <a:endParaRPr lang="en-US" sz="1600">
                         <a:solidFill>
@@ -6390,7 +6390,7 @@
                       <a:tailEnd type="none" w="med" len="med"/>
                     </a:lnB>
                     <a:solidFill>
-                      <a:srgbClr val="C00000"/>
+                      <a:srgbClr val="00B050"/>
                     </a:solidFill>
                   </a:tcPr>
                 </a:tc>
@@ -6411,7 +6411,7 @@
                           <a:ea typeface="Aptos" pitchFamily="34" charset="-122"/>
                           <a:cs typeface="Aptos" pitchFamily="34" charset="-120"/>
                         </a:rPr>
-                        <a:t>75.00% (3.0:1)</a:t>
+                        <a:t>84.00% (5.3:1)</a:t>
                       </a:r>
                       <a:endParaRPr lang="en-US" sz="1600">
                         <a:solidFill>
@@ -6482,7 +6482,7 @@
                           <a:ea typeface="Aptos" pitchFamily="34" charset="-122"/>
                           <a:cs typeface="Aptos" pitchFamily="34" charset="-120"/>
                         </a:rPr>
-                        <a:t>58.00% (1.4:1)</a:t>
+                        <a:t>64.00% (1.8:1)</a:t>
                       </a:r>
                       <a:endParaRPr lang="en-US" sz="1600">
                         <a:solidFill>
@@ -6532,7 +6532,7 @@
                       <a:tailEnd type="none" w="med" len="med"/>
                     </a:lnB>
                     <a:solidFill>
-                      <a:srgbClr val="FFC000"/>
+                      <a:srgbClr val="00B050"/>
                     </a:solidFill>
                   </a:tcPr>
                 </a:tc>
@@ -6553,7 +6553,7 @@
                           <a:ea typeface="Aptos" pitchFamily="34" charset="-122"/>
                           <a:cs typeface="Aptos" pitchFamily="34" charset="-120"/>
                         </a:rPr>
-                        <a:t>No Data</a:t>
+                        <a:t>2.80 days</a:t>
                       </a:r>
                       <a:endParaRPr lang="en-US" sz="1600">
                         <a:solidFill>
@@ -6603,7 +6603,7 @@
                       <a:tailEnd type="none" w="med" len="med"/>
                     </a:lnB>
                     <a:solidFill>
-                      <a:srgbClr val="E7EAED"/>
+                      <a:srgbClr val="00B050"/>
                     </a:solidFill>
                   </a:tcPr>
                 </a:tc>
@@ -6624,7 +6624,7 @@
                           <a:ea typeface="Aptos" pitchFamily="34" charset="-122"/>
                           <a:cs typeface="Aptos" pitchFamily="34" charset="-120"/>
                         </a:rPr>
-                        <a:t>99.00%</a:t>
+                        <a:t>100.00%</a:t>
                       </a:r>
                       <a:endParaRPr lang="en-US" sz="1600">
                         <a:solidFill>
@@ -6674,7 +6674,7 @@
                       <a:tailEnd type="none" w="med" len="med"/>
                     </a:lnB>
                     <a:solidFill>
-                      <a:srgbClr val="FFC000"/>
+                      <a:srgbClr val="00B050"/>
                     </a:solidFill>
                   </a:tcPr>
                 </a:tc>
@@ -6770,7 +6770,7 @@
                           <a:ea typeface="Aptos" charset="0"/>
                           <a:cs typeface="Aptos" charset="0"/>
                         </a:rPr>
-                        <a:t>16.50%</a:t>
+                        <a:t>95.00%</a:t>
                       </a:r>
                     </a:p>
                   </a:txBody>
@@ -6812,7 +6812,7 @@
                       <a:tailEnd type="none" w="med" len="med"/>
                     </a:lnB>
                     <a:solidFill>
-                      <a:srgbClr val="C00000"/>
+                      <a:srgbClr val="00B050"/>
                     </a:solidFill>
                   </a:tcPr>
                 </a:tc>
@@ -6833,7 +6833,7 @@
                           <a:ea typeface="Aptos" pitchFamily="34" charset="-122"/>
                           <a:cs typeface="Aptos" pitchFamily="34" charset="-120"/>
                         </a:rPr>
-                        <a:t>No Data</a:t>
+                        <a:t>98.00%</a:t>
                       </a:r>
                       <a:endParaRPr lang="en-US" sz="1600">
                         <a:solidFill>
@@ -6883,7 +6883,7 @@
                       <a:tailEnd type="none" w="med" len="med"/>
                     </a:lnB>
                     <a:solidFill>
-                      <a:srgbClr val="E7EAED"/>
+                      <a:srgbClr val="00B050"/>
                     </a:solidFill>
                   </a:tcPr>
                 </a:tc>
@@ -6904,7 +6904,7 @@
                           <a:ea typeface="Aptos" pitchFamily="34" charset="-122"/>
                           <a:cs typeface="Aptos" pitchFamily="34" charset="-120"/>
                         </a:rPr>
-                        <a:t>75.00% (3.0:1)</a:t>
+                        <a:t>84.00% (5.3:1)</a:t>
                       </a:r>
                       <a:endParaRPr lang="en-US" sz="1600">
                         <a:solidFill>
@@ -6975,78 +6975,7 @@
                           <a:ea typeface="Aptos" pitchFamily="34" charset="-122"/>
                           <a:cs typeface="Aptos" pitchFamily="34" charset="-120"/>
                         </a:rPr>
-                        <a:t>No Data</a:t>
-                      </a:r>
-                      <a:endParaRPr lang="en-US" sz="1600">
-                        <a:solidFill>
-                          <a:schemeClr val="tx1"/>
-                        </a:solidFill>
-                        <a:latin typeface="Aptos Display"/>
-                        <a:ea typeface="Aptos" charset="0"/>
-                        <a:cs typeface="Aptos" charset="0"/>
-                      </a:endParaRPr>
-                    </a:p>
-                  </a:txBody>
-                  <a:tcPr marL="36576" marR="36576" marT="27432" marB="27432" anchor="ctr">
-                    <a:lnL w="6350" cap="flat" cmpd="sng" algn="ctr">
-                      <a:solidFill>
-                        <a:srgbClr val="E5E7EB"/>
-                      </a:solidFill>
-                      <a:prstDash val="solid"/>
-                      <a:round/>
-                      <a:headEnd type="none" w="med" len="med"/>
-                      <a:tailEnd type="none" w="med" len="med"/>
-                    </a:lnL>
-                    <a:lnR w="6350" cap="flat" cmpd="sng" algn="ctr">
-                      <a:solidFill>
-                        <a:srgbClr val="E5E7EB"/>
-                      </a:solidFill>
-                      <a:prstDash val="solid"/>
-                      <a:round/>
-                      <a:headEnd type="none" w="med" len="med"/>
-                      <a:tailEnd type="none" w="med" len="med"/>
-                    </a:lnR>
-                    <a:lnT w="6350" cap="flat" cmpd="sng" algn="ctr">
-                      <a:solidFill>
-                        <a:srgbClr val="E5E7EB"/>
-                      </a:solidFill>
-                      <a:prstDash val="solid"/>
-                      <a:round/>
-                      <a:headEnd type="none" w="med" len="med"/>
-                      <a:tailEnd type="none" w="med" len="med"/>
-                    </a:lnT>
-                    <a:lnB w="6350" cap="flat" cmpd="sng" algn="ctr">
-                      <a:solidFill>
-                        <a:srgbClr val="E5E7EB"/>
-                      </a:solidFill>
-                      <a:prstDash val="solid"/>
-                      <a:round/>
-                      <a:headEnd type="none" w="med" len="med"/>
-                      <a:tailEnd type="none" w="med" len="med"/>
-                    </a:lnB>
-                    <a:solidFill>
-                      <a:srgbClr val="E7EAED"/>
-                    </a:solidFill>
-                  </a:tcPr>
-                </a:tc>
-                <a:tc>
-                  <a:txBody>
-                    <a:bodyPr/>
-                    <a:lstStyle/>
-                    <a:p>
-                      <a:pPr marL="0" indent="0" algn="ctr">
-                        <a:buNone/>
-                      </a:pPr>
-                      <a:r>
-                        <a:rPr lang="en-US" sz="1600">
-                          <a:solidFill>
-                            <a:schemeClr val="tx1"/>
-                          </a:solidFill>
-                          <a:latin typeface="Aptos Display"/>
-                          <a:ea typeface="Aptos" pitchFamily="34" charset="-122"/>
-                          <a:cs typeface="Aptos" pitchFamily="34" charset="-120"/>
-                        </a:rPr>
-                        <a:t>12.00 days</a:t>
+                        <a:t>66.00% (1.9:1)</a:t>
                       </a:r>
                       <a:endParaRPr lang="en-US" sz="1600">
                         <a:solidFill>
@@ -7117,7 +7046,7 @@
                           <a:ea typeface="Aptos" pitchFamily="34" charset="-122"/>
                           <a:cs typeface="Aptos" pitchFamily="34" charset="-120"/>
                         </a:rPr>
-                        <a:t>99.96%</a:t>
+                        <a:t>2.80 days</a:t>
                       </a:r>
                       <a:endParaRPr lang="en-US" sz="1600">
                         <a:solidFill>
@@ -7167,7 +7096,78 @@
                       <a:tailEnd type="none" w="med" len="med"/>
                     </a:lnB>
                     <a:solidFill>
-                      <a:srgbClr val="FFC000"/>
+                      <a:srgbClr val="00B050"/>
+                    </a:solidFill>
+                  </a:tcPr>
+                </a:tc>
+                <a:tc>
+                  <a:txBody>
+                    <a:bodyPr/>
+                    <a:lstStyle/>
+                    <a:p>
+                      <a:pPr marL="0" indent="0" algn="ctr">
+                        <a:buNone/>
+                      </a:pPr>
+                      <a:r>
+                        <a:rPr lang="en-US" sz="1600">
+                          <a:solidFill>
+                            <a:schemeClr val="tx1"/>
+                          </a:solidFill>
+                          <a:latin typeface="Aptos Display"/>
+                          <a:ea typeface="Aptos" pitchFamily="34" charset="-122"/>
+                          <a:cs typeface="Aptos" pitchFamily="34" charset="-120"/>
+                        </a:rPr>
+                        <a:t>100.00%</a:t>
+                      </a:r>
+                      <a:endParaRPr lang="en-US" sz="1600">
+                        <a:solidFill>
+                          <a:schemeClr val="tx1"/>
+                        </a:solidFill>
+                        <a:latin typeface="Aptos Display"/>
+                        <a:ea typeface="Aptos" charset="0"/>
+                        <a:cs typeface="Aptos" charset="0"/>
+                      </a:endParaRPr>
+                    </a:p>
+                  </a:txBody>
+                  <a:tcPr marL="36576" marR="36576" marT="27432" marB="27432" anchor="ctr">
+                    <a:lnL w="6350" cap="flat" cmpd="sng" algn="ctr">
+                      <a:solidFill>
+                        <a:srgbClr val="E5E7EB"/>
+                      </a:solidFill>
+                      <a:prstDash val="solid"/>
+                      <a:round/>
+                      <a:headEnd type="none" w="med" len="med"/>
+                      <a:tailEnd type="none" w="med" len="med"/>
+                    </a:lnL>
+                    <a:lnR w="6350" cap="flat" cmpd="sng" algn="ctr">
+                      <a:solidFill>
+                        <a:srgbClr val="E5E7EB"/>
+                      </a:solidFill>
+                      <a:prstDash val="solid"/>
+                      <a:round/>
+                      <a:headEnd type="none" w="med" len="med"/>
+                      <a:tailEnd type="none" w="med" len="med"/>
+                    </a:lnR>
+                    <a:lnT w="6350" cap="flat" cmpd="sng" algn="ctr">
+                      <a:solidFill>
+                        <a:srgbClr val="E5E7EB"/>
+                      </a:solidFill>
+                      <a:prstDash val="solid"/>
+                      <a:round/>
+                      <a:headEnd type="none" w="med" len="med"/>
+                      <a:tailEnd type="none" w="med" len="med"/>
+                    </a:lnT>
+                    <a:lnB w="6350" cap="flat" cmpd="sng" algn="ctr">
+                      <a:solidFill>
+                        <a:srgbClr val="E5E7EB"/>
+                      </a:solidFill>
+                      <a:prstDash val="solid"/>
+                      <a:round/>
+                      <a:headEnd type="none" w="med" len="med"/>
+                      <a:tailEnd type="none" w="med" len="med"/>
+                    </a:lnB>
+                    <a:solidFill>
+                      <a:srgbClr val="00B050"/>
                     </a:solidFill>
                   </a:tcPr>
                 </a:tc>
@@ -8687,7 +8687,7 @@
                           <a:ea typeface="Aptos" pitchFamily="34" charset="-122"/>
                           <a:cs typeface="Aptos" pitchFamily="34" charset="-120"/>
                         </a:rPr>
-                        <a:t>98.00%</a:t>
+                        <a:t>99.00%</a:t>
                       </a:r>
                       <a:endParaRPr lang="en-US" sz="1600">
                         <a:solidFill>
@@ -8758,7 +8758,7 @@
                           <a:ea typeface="Aptos" pitchFamily="34" charset="-122"/>
                           <a:cs typeface="Aptos" pitchFamily="34" charset="-120"/>
                         </a:rPr>
-                        <a:t>100.00%</a:t>
+                        <a:t>102.00%</a:t>
                       </a:r>
                       <a:endParaRPr lang="en-US" sz="1600">
                         <a:solidFill>
@@ -8829,7 +8829,7 @@
                           <a:ea typeface="Aptos" pitchFamily="34" charset="-122"/>
                           <a:cs typeface="Aptos" pitchFamily="34" charset="-120"/>
                         </a:rPr>
-                        <a:t>92.00% (11.5:1)</a:t>
+                        <a:t>88.00% (7.3:1)</a:t>
                       </a:r>
                       <a:endParaRPr lang="en-US" sz="1600">
                         <a:solidFill>
@@ -8900,7 +8900,7 @@
                           <a:ea typeface="Aptos" pitchFamily="34" charset="-122"/>
                           <a:cs typeface="Aptos" pitchFamily="34" charset="-120"/>
                         </a:rPr>
-                        <a:t>70.00% (2.3:1)</a:t>
+                        <a:t>68.00% (2.1:1)</a:t>
                       </a:r>
                       <a:endParaRPr lang="en-US" sz="1600">
                         <a:solidFill>
@@ -8971,7 +8971,7 @@
                           <a:ea typeface="Aptos" pitchFamily="34" charset="-122"/>
                           <a:cs typeface="Aptos" pitchFamily="34" charset="-120"/>
                         </a:rPr>
-                        <a:t>2.40 days</a:t>
+                        <a:t>4.20 days</a:t>
                       </a:r>
                       <a:endParaRPr lang="en-US" sz="1600">
                         <a:solidFill>

</xml_diff>